<commit_message>
Improve xsum answer visibility and citation wording
</commit_message>
<xml_diff>
--- a/slides/datasets-in-10-minutes-xsum.pptx
+++ b/slides/datasets-in-10-minutes-xsum.pptx
@@ -11848,7 +11848,7 @@
                 <a:ea typeface="Noto Sans CJK JP"/>
                 <a:cs typeface="Noto Sans"/>
               </a:rPr>
-              <a:t>論文Table 1の本文平均431.07語・要約23.26語は、全体と論文の前処理による集計である。今回のtestの空白区切り集計とは条件が異なる。</a:t>
+              <a:t>構築時の本文平均431.07語・要約23.26語は、全体と論文の前処理による集計である。今回のtestの空白区切り集計とは条件が異なる。</a:t>
             </a:r>
           </a:p>
         </p:txBody>
@@ -14145,7 +14145,7 @@
                 <a:ea typeface="Noto Sans CJK JP"/>
                 <a:cs typeface="Noto Sans"/>
               </a:rPr>
-              <a:t>論文Table 4。test全件に対するROUGE F1×100。最後の行はenc(t′,tD), dec(tD)。</a:t>
+              <a:t>test全件に対するROUGE F1×100。最後の行はenc(t′,tD), dec(tD)。</a:t>
             </a:r>
           </a:p>
         </p:txBody>
@@ -16919,7 +16919,7 @@
                 <a:ea typeface="Noto Sans CJK JP"/>
                 <a:cs typeface="Noto Sans"/>
               </a:rPr>
-              <a:t>BART論文Table 4。XSumで微調整したモデル。HELMの518件・少数例提示とは条件が異なる。</a:t>
+              <a:t>BARTXSumで微調整したモデル。HELMの518件・少数例提示とは条件が異なる。</a:t>
             </a:r>
           </a:p>
         </p:txBody>

</xml_diff>